<commit_message>
docs & chore: finalize report, presentation slides, clean obsolete files and update completion status
</commit_message>
<xml_diff>
--- a/reports/slides/NLP_ITviec_Sentiment_Slides.pptx
+++ b/reports/slides/NLP_ITviec_Sentiment_Slides.pptx
@@ -6215,7 +6215,7 @@
                 </a:solidFill>
                 <a:latin typeface="Segoe UI"/>
               </a:rPr>
-              <a:t>ĐỒ ÁN TỐT NGHIỆP — MÔN XỬ LÝ NGÔN NGỮ TỰ NHIÊN</a:t>
+              <a:t>ĐỒ ÁN CUỐI KỲ— MÔN XỬ LÝ NGÔN NGỮ TỰ NHIÊN</a:t>
             </a:r>
           </a:p>
         </p:txBody>
@@ -6478,7 +6478,7 @@
                 </a:solidFill>
                 <a:latin typeface="Segoe UI"/>
               </a:rPr>
-              <a:t>Khoa Công nghệ Thông tin</a:t>
+              <a:t>Khoa Khoa học Máy tính</a:t>
             </a:r>
           </a:p>
         </p:txBody>
@@ -6517,7 +6517,7 @@
                 </a:solidFill>
                 <a:latin typeface="Segoe UI"/>
               </a:rPr>
-              <a:t>NHÓM THỰC HIỆN — NHÓM 4</a:t>
+              <a:t>NHÓM THỰC HIỆN — NHÓM 12</a:t>
             </a:r>
           </a:p>
         </p:txBody>
@@ -6530,7 +6530,7 @@
         </p:nvSpPr>
         <p:spPr>
           <a:xfrm>
-            <a:off x="4251959" y="4270248"/>
+            <a:off x="4251959" y="4233672"/>
             <a:ext cx="3383280" cy="237744"/>
           </a:xfrm>
           <a:prstGeom prst="rect">
@@ -6550,13 +6550,13 @@
               </a:lnSpc>
             </a:pPr>
             <a:r>
-              <a:rPr sz="1080" b="0">
+              <a:rPr sz="1019" b="0">
                 <a:solidFill>
                   <a:srgbClr val="A0ADBF"/>
                 </a:solidFill>
                 <a:latin typeface="Segoe UI"/>
               </a:rPr>
-              <a:t>Hoàng Hôn  ·  Trưởng nhóm / Tech Lead</a:t>
+              <a:t>Trần Hoàng Hôn (26410046) · Trưởng nhóm / Tech Lead</a:t>
             </a:r>
           </a:p>
         </p:txBody>
@@ -6569,7 +6569,7 @@
         </p:nvSpPr>
         <p:spPr>
           <a:xfrm>
-            <a:off x="4251959" y="4494276"/>
+            <a:off x="4251959" y="4462272"/>
             <a:ext cx="3383280" cy="237744"/>
           </a:xfrm>
           <a:prstGeom prst="rect">
@@ -6589,13 +6589,13 @@
               </a:lnSpc>
             </a:pPr>
             <a:r>
-              <a:rPr sz="1080" b="0">
+              <a:rPr sz="1019" b="0">
                 <a:solidFill>
                   <a:srgbClr val="A0ADBF"/>
                 </a:solidFill>
                 <a:latin typeface="Segoe UI"/>
               </a:rPr>
-              <a:t>Văn Duy  ·  Data &amp; Research Specialist</a:t>
+              <a:t>Nguyễn Duy Khang (26410055) · ML Specialist</a:t>
             </a:r>
           </a:p>
         </p:txBody>
@@ -6608,7 +6608,7 @@
         </p:nvSpPr>
         <p:spPr>
           <a:xfrm>
-            <a:off x="4251959" y="4718304"/>
+            <a:off x="4251959" y="4690872"/>
             <a:ext cx="3383280" cy="237744"/>
           </a:xfrm>
           <a:prstGeom prst="rect">
@@ -6628,13 +6628,13 @@
               </a:lnSpc>
             </a:pPr>
             <a:r>
-              <a:rPr sz="1080" b="0">
+              <a:rPr sz="1019" b="0">
                 <a:solidFill>
                   <a:srgbClr val="A0ADBF"/>
                 </a:solidFill>
                 <a:latin typeface="Segoe UI"/>
               </a:rPr>
-              <a:t>Duy Khang  ·  Machine Learning Specialist</a:t>
+              <a:t>Vũ Văn Duy (26410031) · Data &amp; Research</a:t>
             </a:r>
           </a:p>
         </p:txBody>
@@ -6647,7 +6647,7 @@
         </p:nvSpPr>
         <p:spPr>
           <a:xfrm>
-            <a:off x="4251959" y="4942332"/>
+            <a:off x="4251959" y="4919472"/>
             <a:ext cx="3383280" cy="237744"/>
           </a:xfrm>
           <a:prstGeom prst="rect">
@@ -6667,13 +6667,13 @@
               </a:lnSpc>
             </a:pPr>
             <a:r>
-              <a:rPr sz="1080" b="0">
+              <a:rPr sz="1019" b="0">
                 <a:solidFill>
                   <a:srgbClr val="A0ADBF"/>
                 </a:solidFill>
                 <a:latin typeface="Segoe UI"/>
               </a:rPr>
-              <a:t>Thành Trung  ·  UI/UX &amp; Deployment Specialist</a:t>
+              <a:t>Phạm Thành Trung (26410141) · UI/UX &amp; Demo</a:t>
             </a:r>
           </a:p>
         </p:txBody>
@@ -7170,6 +7170,130 @@
                 <a:latin typeface="Segoe UI"/>
               </a:rPr>
               <a:t>test passed</a:t>
+            </a:r>
+          </a:p>
+        </p:txBody>
+      </p:sp>
+      <p:sp>
+        <p:nvSpPr>
+          <p:cNvPr id="96" name="Rectangle 95"/>
+          <p:cNvSpPr/>
+          <p:nvPr/>
+        </p:nvSpPr>
+        <p:spPr>
+          <a:xfrm>
+            <a:off x="502920" y="5394960"/>
+            <a:ext cx="10789920" cy="804672"/>
+          </a:xfrm>
+          <a:prstGeom prst="rect">
+            <a:avLst/>
+          </a:prstGeom>
+          <a:solidFill>
+            <a:srgbClr val="141A24"/>
+          </a:solidFill>
+          <a:ln w="12700">
+            <a:solidFill>
+              <a:srgbClr val="242C3A"/>
+            </a:solidFill>
+          </a:ln>
+          <a:effectLst/>
+        </p:spPr>
+        <p:style>
+          <a:lnRef idx="1">
+            <a:schemeClr val="accent1"/>
+          </a:lnRef>
+          <a:fillRef idx="3">
+            <a:schemeClr val="accent1"/>
+          </a:fillRef>
+          <a:effectRef idx="2">
+            <a:schemeClr val="accent1"/>
+          </a:effectRef>
+          <a:fontRef idx="minor">
+            <a:schemeClr val="lt1"/>
+          </a:fontRef>
+        </p:style>
+        <p:txBody>
+          <a:bodyPr rtlCol="0" anchor="ctr"/>
+          <a:lstStyle/>
+          <a:p>
+            <a:pPr algn="ctr"/>
+          </a:p>
+        </p:txBody>
+      </p:sp>
+      <p:sp>
+        <p:nvSpPr>
+          <p:cNvPr id="97" name="TextBox 96"/>
+          <p:cNvSpPr txBox="1"/>
+          <p:nvPr/>
+        </p:nvSpPr>
+        <p:spPr>
+          <a:xfrm>
+            <a:off x="731520" y="5468112"/>
+            <a:ext cx="5486400" cy="228600"/>
+          </a:xfrm>
+          <a:prstGeom prst="rect">
+            <a:avLst/>
+          </a:prstGeom>
+          <a:noFill/>
+        </p:spPr>
+        <p:txBody>
+          <a:bodyPr wrap="square" anchor="t" lIns="0" rIns="0" tIns="0" bIns="0">
+            <a:spAutoFit/>
+          </a:bodyPr>
+          <a:lstStyle/>
+          <a:p>
+            <a:pPr algn="l">
+              <a:lnSpc>
+                <a:spcPct val="100000"/>
+              </a:lnSpc>
+            </a:pPr>
+            <a:r>
+              <a:rPr sz="950" b="1">
+                <a:solidFill>
+                  <a:srgbClr val="7AA7FF"/>
+                </a:solidFill>
+                <a:latin typeface="Segoe UI"/>
+              </a:rPr>
+              <a:t>KHO LƯU TRỮ MÃ NGUỒN GITHUB &amp; DEMO</a:t>
+            </a:r>
+          </a:p>
+        </p:txBody>
+      </p:sp>
+      <p:sp>
+        <p:nvSpPr>
+          <p:cNvPr id="98" name="TextBox 97"/>
+          <p:cNvSpPr txBox="1"/>
+          <p:nvPr/>
+        </p:nvSpPr>
+        <p:spPr>
+          <a:xfrm>
+            <a:off x="731520" y="5715000"/>
+            <a:ext cx="10332720" cy="347472"/>
+          </a:xfrm>
+          <a:prstGeom prst="rect">
+            <a:avLst/>
+          </a:prstGeom>
+          <a:noFill/>
+        </p:spPr>
+        <p:txBody>
+          <a:bodyPr wrap="square" anchor="t" lIns="0" rIns="0" tIns="0" bIns="0">
+            <a:spAutoFit/>
+          </a:bodyPr>
+          <a:lstStyle/>
+          <a:p>
+            <a:pPr algn="l">
+              <a:lnSpc>
+                <a:spcPct val="100000"/>
+              </a:lnSpc>
+            </a:pPr>
+            <a:r>
+              <a:rPr sz="1350" b="1">
+                <a:solidFill>
+                  <a:srgbClr val="50E3A4"/>
+                </a:solidFill>
+                <a:latin typeface="Segoe UI"/>
+              </a:rPr>
+              <a:t>https://github.com/mrkiss-it/NLP-Sentiment-Analysis-ITviec</a:t>
             </a:r>
           </a:p>
         </p:txBody>
@@ -7660,7 +7784,7 @@
                 </a:solidFill>
                 <a:latin typeface="Segoe UI"/>
               </a:rPr>
-              <a:t>Phân tích Cảm xúc Đánh giá ITviec  ·  Nhóm 4</a:t>
+              <a:t>Phân tích Cảm xúc Đánh giá ITviec  ·  Nhóm 12</a:t>
             </a:r>
           </a:p>
         </p:txBody>
@@ -7699,7 +7823,7 @@
                 </a:solidFill>
                 <a:latin typeface="Segoe UI"/>
               </a:rPr>
-              <a:t>09 / 15</a:t>
+              <a:t>10 / 15</a:t>
             </a:r>
           </a:p>
         </p:txBody>
@@ -9212,7 +9336,7 @@
                 </a:solidFill>
                 <a:latin typeface="Segoe UI"/>
               </a:rPr>
-              <a:t>Phân tích Cảm xúc Đánh giá ITviec  ·  Nhóm 4</a:t>
+              <a:t>Phân tích Cảm xúc Đánh giá ITviec  ·  Nhóm 12</a:t>
             </a:r>
           </a:p>
         </p:txBody>
@@ -9251,7 +9375,7 @@
                 </a:solidFill>
                 <a:latin typeface="Segoe UI"/>
               </a:rPr>
-              <a:t>10 / 15</a:t>
+              <a:t>11 / 15</a:t>
             </a:r>
           </a:p>
         </p:txBody>
@@ -10583,7 +10707,7 @@
                 </a:solidFill>
                 <a:latin typeface="Segoe UI"/>
               </a:rPr>
-              <a:t>Phân tích Cảm xúc Đánh giá ITviec  ·  Nhóm 4</a:t>
+              <a:t>Phân tích Cảm xúc Đánh giá ITviec  ·  Nhóm 12</a:t>
             </a:r>
           </a:p>
         </p:txBody>
@@ -10622,7 +10746,7 @@
                 </a:solidFill>
                 <a:latin typeface="Segoe UI"/>
               </a:rPr>
-              <a:t>11 / 15</a:t>
+              <a:t>12 / 15</a:t>
             </a:r>
           </a:p>
         </p:txBody>
@@ -12684,7 +12808,7 @@
                 </a:solidFill>
                 <a:latin typeface="Segoe UI"/>
               </a:rPr>
-              <a:t>Phân tích Cảm xúc Đánh giá ITviec  ·  Nhóm 4</a:t>
+              <a:t>Phân tích Cảm xúc Đánh giá ITviec  ·  Nhóm 12</a:t>
             </a:r>
           </a:p>
         </p:txBody>
@@ -12723,7 +12847,7 @@
                 </a:solidFill>
                 <a:latin typeface="Segoe UI"/>
               </a:rPr>
-              <a:t>12 / 15</a:t>
+              <a:t>13 / 15</a:t>
             </a:r>
           </a:p>
         </p:txBody>
@@ -14533,7 +14657,7 @@
                 </a:solidFill>
                 <a:latin typeface="Segoe UI"/>
               </a:rPr>
-              <a:t>Phân tích Cảm xúc Đánh giá ITviec  ·  Nhóm 4</a:t>
+              <a:t>Phân tích Cảm xúc Đánh giá ITviec  ·  Nhóm 12</a:t>
             </a:r>
           </a:p>
         </p:txBody>
@@ -14572,7 +14696,7 @@
                 </a:solidFill>
                 <a:latin typeface="Segoe UI"/>
               </a:rPr>
-              <a:t>13 / 15</a:t>
+              <a:t>14 / 15</a:t>
             </a:r>
           </a:p>
         </p:txBody>
@@ -16280,7 +16404,7 @@
                 </a:solidFill>
                 <a:latin typeface="Segoe UI"/>
               </a:rPr>
-              <a:t>Phân tích Cảm xúc Đánh giá ITviec  ·  Nhóm 4</a:t>
+              <a:t>Phân tích Cảm xúc Đánh giá ITviec  ·  Nhóm 12</a:t>
             </a:r>
           </a:p>
         </p:txBody>
@@ -16319,7 +16443,7 @@
                 </a:solidFill>
                 <a:latin typeface="Segoe UI"/>
               </a:rPr>
-              <a:t>14 / 15</a:t>
+              <a:t>15 / 15</a:t>
             </a:r>
           </a:p>
         </p:txBody>
@@ -17260,7 +17384,7 @@
                 </a:solidFill>
                 <a:latin typeface="Segoe UI"/>
               </a:rPr>
-              <a:t>Nhóm 4 xin chân thành cảm ơn Thầy Đặng Văn Thìn đã tận tình hướng dẫn, cùng Hội đồng đánh giá đã dành thời gian theo dõi phần trình bày của nhóm.</a:t>
+              <a:t>Nhóm 12 xin chân thành cảm ơn Thầy Đặng Văn Thìn và các bạn đã dành thời gian theo dõi phần trình bày của nhóm.</a:t>
             </a:r>
           </a:p>
         </p:txBody>
@@ -17912,7 +18036,7 @@
                 </a:solidFill>
                 <a:latin typeface="Segoe UI"/>
               </a:rPr>
-              <a:t>Phân tích Cảm xúc Đánh giá ITviec  ·  Nhóm 4</a:t>
+              <a:t>Phân tích Cảm xúc Đánh giá ITviec  ·  Nhóm 12</a:t>
             </a:r>
           </a:p>
         </p:txBody>
@@ -17951,7 +18075,7 @@
                 </a:solidFill>
                 <a:latin typeface="Segoe UI"/>
               </a:rPr>
-              <a:t>01 / 15</a:t>
+              <a:t>02 / 15</a:t>
             </a:r>
           </a:p>
         </p:txBody>
@@ -19556,7 +19680,7 @@
                 </a:solidFill>
                 <a:latin typeface="Segoe UI"/>
               </a:rPr>
-              <a:t>Phân tích Cảm xúc Đánh giá ITviec  ·  Nhóm 4</a:t>
+              <a:t>Phân tích Cảm xúc Đánh giá ITviec  ·  Nhóm 12</a:t>
             </a:r>
           </a:p>
         </p:txBody>
@@ -19595,7 +19719,7 @@
                 </a:solidFill>
                 <a:latin typeface="Segoe UI"/>
               </a:rPr>
-              <a:t>02 / 15</a:t>
+              <a:t>03 / 15</a:t>
             </a:r>
           </a:p>
         </p:txBody>
@@ -21740,7 +21864,7 @@
                 </a:solidFill>
                 <a:latin typeface="Segoe UI"/>
               </a:rPr>
-              <a:t>Phân tích Cảm xúc Đánh giá ITviec  ·  Nhóm 4</a:t>
+              <a:t>Phân tích Cảm xúc Đánh giá ITviec  ·  Nhóm 12</a:t>
             </a:r>
           </a:p>
         </p:txBody>
@@ -21779,7 +21903,7 @@
                 </a:solidFill>
                 <a:latin typeface="Segoe UI"/>
               </a:rPr>
-              <a:t>03 / 15</a:t>
+              <a:t>04 / 15</a:t>
             </a:r>
           </a:p>
         </p:txBody>
@@ -23796,7 +23920,7 @@
                 </a:solidFill>
                 <a:latin typeface="Segoe UI"/>
               </a:rPr>
-              <a:t>Phân tích Cảm xúc Đánh giá ITviec  ·  Nhóm 4</a:t>
+              <a:t>Phân tích Cảm xúc Đánh giá ITviec  ·  Nhóm 12</a:t>
             </a:r>
           </a:p>
         </p:txBody>
@@ -23835,7 +23959,7 @@
                 </a:solidFill>
                 <a:latin typeface="Segoe UI"/>
               </a:rPr>
-              <a:t>04 / 15</a:t>
+              <a:t>05 / 15</a:t>
             </a:r>
           </a:p>
         </p:txBody>
@@ -24653,7 +24777,7 @@
                 </a:solidFill>
                 <a:latin typeface="Segoe UI"/>
               </a:rPr>
-              <a:t>Phân tích Cảm xúc Đánh giá ITviec  ·  Nhóm 4</a:t>
+              <a:t>Phân tích Cảm xúc Đánh giá ITviec  ·  Nhóm 12</a:t>
             </a:r>
           </a:p>
         </p:txBody>
@@ -24692,7 +24816,7 @@
                 </a:solidFill>
                 <a:latin typeface="Segoe UI"/>
               </a:rPr>
-              <a:t>05 / 15</a:t>
+              <a:t>06 / 15</a:t>
             </a:r>
           </a:p>
         </p:txBody>
@@ -25804,7 +25928,7 @@
                 </a:solidFill>
                 <a:latin typeface="Segoe UI"/>
               </a:rPr>
-              <a:t>Phân tích Cảm xúc Đánh giá ITviec  ·  Nhóm 4</a:t>
+              <a:t>Phân tích Cảm xúc Đánh giá ITviec  ·  Nhóm 12</a:t>
             </a:r>
           </a:p>
         </p:txBody>
@@ -25843,7 +25967,7 @@
                 </a:solidFill>
                 <a:latin typeface="Segoe UI"/>
               </a:rPr>
-              <a:t>06 / 15</a:t>
+              <a:t>07 / 15</a:t>
             </a:r>
           </a:p>
         </p:txBody>
@@ -28150,7 +28274,7 @@
                 </a:solidFill>
                 <a:latin typeface="Segoe UI"/>
               </a:rPr>
-              <a:t>Phân tích Cảm xúc Đánh giá ITviec  ·  Nhóm 4</a:t>
+              <a:t>Phân tích Cảm xúc Đánh giá ITviec  ·  Nhóm 12</a:t>
             </a:r>
           </a:p>
         </p:txBody>
@@ -28189,7 +28313,7 @@
                 </a:solidFill>
                 <a:latin typeface="Segoe UI"/>
               </a:rPr>
-              <a:t>07 / 15</a:t>
+              <a:t>08 / 15</a:t>
             </a:r>
           </a:p>
         </p:txBody>
@@ -29841,7 +29965,7 @@
                 </a:solidFill>
                 <a:latin typeface="Segoe UI"/>
               </a:rPr>
-              <a:t>Phân tích Cảm xúc Đánh giá ITviec  ·  Nhóm 4</a:t>
+              <a:t>Phân tích Cảm xúc Đánh giá ITviec  ·  Nhóm 12</a:t>
             </a:r>
           </a:p>
         </p:txBody>
@@ -29880,7 +30004,7 @@
                 </a:solidFill>
                 <a:latin typeface="Segoe UI"/>
               </a:rPr>
-              <a:t>08 / 15</a:t>
+              <a:t>09 / 15</a:t>
             </a:r>
           </a:p>
         </p:txBody>

</xml_diff>